<commit_message>
Model delivery and garage walls in Godot
</commit_message>
<xml_diff>
--- a/docs/a1_course_layout.pptx
+++ b/docs/a1_course_layout.pptx
@@ -104,6 +104,11 @@
       </a:defRPr>
     </a:lvl9pPr>
   </p:defaultTextStyle>
+  <p:extLst>
+    <p:ext uri="{EFAFB233-063F-42B5-8137-9DF3F51BA10A}">
+      <p15:sldGuideLst xmlns:p15="http://schemas.microsoft.com/office/powerpoint/2012/main"/>
+    </p:ext>
+  </p:extLst>
 </p:presentation>
 </file>
 
@@ -238,7 +243,7 @@
           <a:p>
             <a:fld id="{7AC65EF0-2E7B-4047-B95B-8A1ED9DB78AD}" type="datetimeFigureOut">
               <a:rPr kumimoji="1" lang="ja-JP" altLang="en-US" smtClean="0"/>
-              <a:t>2026/8/9</a:t>
+              <a:t>2026/8/10</a:t>
             </a:fld>
             <a:endParaRPr kumimoji="1" lang="ja-JP" altLang="en-US"/>
           </a:p>
@@ -440,7 +445,7 @@
           <a:p>
             <a:fld id="{7AC65EF0-2E7B-4047-B95B-8A1ED9DB78AD}" type="datetimeFigureOut">
               <a:rPr kumimoji="1" lang="ja-JP" altLang="en-US" smtClean="0"/>
-              <a:t>2026/8/9</a:t>
+              <a:t>2026/8/10</a:t>
             </a:fld>
             <a:endParaRPr kumimoji="1" lang="ja-JP" altLang="en-US"/>
           </a:p>
@@ -652,7 +657,7 @@
           <a:p>
             <a:fld id="{7AC65EF0-2E7B-4047-B95B-8A1ED9DB78AD}" type="datetimeFigureOut">
               <a:rPr kumimoji="1" lang="ja-JP" altLang="en-US" smtClean="0"/>
-              <a:t>2026/8/9</a:t>
+              <a:t>2026/8/10</a:t>
             </a:fld>
             <a:endParaRPr kumimoji="1" lang="ja-JP" altLang="en-US"/>
           </a:p>
@@ -854,7 +859,7 @@
           <a:p>
             <a:fld id="{7AC65EF0-2E7B-4047-B95B-8A1ED9DB78AD}" type="datetimeFigureOut">
               <a:rPr kumimoji="1" lang="ja-JP" altLang="en-US" smtClean="0"/>
-              <a:t>2026/8/9</a:t>
+              <a:t>2026/8/10</a:t>
             </a:fld>
             <a:endParaRPr kumimoji="1" lang="ja-JP" altLang="en-US"/>
           </a:p>
@@ -1100,7 +1105,7 @@
           <a:p>
             <a:fld id="{7AC65EF0-2E7B-4047-B95B-8A1ED9DB78AD}" type="datetimeFigureOut">
               <a:rPr kumimoji="1" lang="ja-JP" altLang="en-US" smtClean="0"/>
-              <a:t>2026/8/9</a:t>
+              <a:t>2026/8/10</a:t>
             </a:fld>
             <a:endParaRPr kumimoji="1" lang="ja-JP" altLang="en-US"/>
           </a:p>
@@ -1396,7 +1401,7 @@
           <a:p>
             <a:fld id="{7AC65EF0-2E7B-4047-B95B-8A1ED9DB78AD}" type="datetimeFigureOut">
               <a:rPr kumimoji="1" lang="ja-JP" altLang="en-US" smtClean="0"/>
-              <a:t>2026/8/9</a:t>
+              <a:t>2026/8/10</a:t>
             </a:fld>
             <a:endParaRPr kumimoji="1" lang="ja-JP" altLang="en-US"/>
           </a:p>
@@ -1827,7 +1832,7 @@
           <a:p>
             <a:fld id="{7AC65EF0-2E7B-4047-B95B-8A1ED9DB78AD}" type="datetimeFigureOut">
               <a:rPr kumimoji="1" lang="ja-JP" altLang="en-US" smtClean="0"/>
-              <a:t>2026/8/9</a:t>
+              <a:t>2026/8/10</a:t>
             </a:fld>
             <a:endParaRPr kumimoji="1" lang="ja-JP" altLang="en-US"/>
           </a:p>
@@ -1945,7 +1950,7 @@
           <a:p>
             <a:fld id="{7AC65EF0-2E7B-4047-B95B-8A1ED9DB78AD}" type="datetimeFigureOut">
               <a:rPr kumimoji="1" lang="ja-JP" altLang="en-US" smtClean="0"/>
-              <a:t>2026/8/9</a:t>
+              <a:t>2026/8/10</a:t>
             </a:fld>
             <a:endParaRPr kumimoji="1" lang="ja-JP" altLang="en-US"/>
           </a:p>
@@ -2040,7 +2045,7 @@
           <a:p>
             <a:fld id="{7AC65EF0-2E7B-4047-B95B-8A1ED9DB78AD}" type="datetimeFigureOut">
               <a:rPr kumimoji="1" lang="ja-JP" altLang="en-US" smtClean="0"/>
-              <a:t>2026/8/9</a:t>
+              <a:t>2026/8/10</a:t>
             </a:fld>
             <a:endParaRPr kumimoji="1" lang="ja-JP" altLang="en-US"/>
           </a:p>
@@ -2349,7 +2354,7 @@
           <a:p>
             <a:fld id="{7AC65EF0-2E7B-4047-B95B-8A1ED9DB78AD}" type="datetimeFigureOut">
               <a:rPr kumimoji="1" lang="ja-JP" altLang="en-US" smtClean="0"/>
-              <a:t>2026/8/9</a:t>
+              <a:t>2026/8/10</a:t>
             </a:fld>
             <a:endParaRPr kumimoji="1" lang="ja-JP" altLang="en-US"/>
           </a:p>
@@ -2606,7 +2611,7 @@
           <a:p>
             <a:fld id="{7AC65EF0-2E7B-4047-B95B-8A1ED9DB78AD}" type="datetimeFigureOut">
               <a:rPr kumimoji="1" lang="ja-JP" altLang="en-US" smtClean="0"/>
-              <a:t>2026/8/9</a:t>
+              <a:t>2026/8/10</a:t>
             </a:fld>
             <a:endParaRPr kumimoji="1" lang="ja-JP" altLang="en-US"/>
           </a:p>
@@ -2851,7 +2856,7 @@
           <a:p>
             <a:fld id="{7AC65EF0-2E7B-4047-B95B-8A1ED9DB78AD}" type="datetimeFigureOut">
               <a:rPr kumimoji="1" lang="ja-JP" altLang="en-US" smtClean="0"/>
-              <a:t>2026/8/9</a:t>
+              <a:t>2026/8/10</a:t>
             </a:fld>
             <a:endParaRPr kumimoji="1" lang="ja-JP" altLang="en-US"/>
           </a:p>
@@ -3405,8 +3410,8 @@
         </p:nvCxnSpPr>
         <p:spPr>
           <a:xfrm flipV="1">
-            <a:off x="27646450" y="10907987"/>
-            <a:ext cx="0" cy="3384000"/>
+            <a:off x="28846600" y="12594940"/>
+            <a:ext cx="0" cy="3060000"/>
           </a:xfrm>
           <a:prstGeom prst="straightConnector1">
             <a:avLst/>
@@ -3448,7 +3453,7 @@
         </p:nvSpPr>
         <p:spPr>
           <a:xfrm>
-            <a:off x="27739778" y="12470332"/>
+            <a:off x="28992123" y="14287120"/>
             <a:ext cx="816249" cy="369332"/>
           </a:xfrm>
           <a:prstGeom prst="rect">
@@ -3464,7 +3469,7 @@
           <a:p>
             <a:r>
               <a:rPr kumimoji="1" lang="en-US" altLang="ja-JP" dirty="0"/>
-              <a:t>9.4cm</a:t>
+              <a:t>8.5cm</a:t>
             </a:r>
             <a:endParaRPr kumimoji="1" lang="ja-JP" altLang="en-US"/>
           </a:p>
@@ -3520,7 +3525,7 @@
         </p:nvSpPr>
         <p:spPr>
           <a:xfrm>
-            <a:off x="12980884" y="15308158"/>
+            <a:off x="10904726" y="15308158"/>
             <a:ext cx="939681" cy="369332"/>
           </a:xfrm>
           <a:prstGeom prst="rect">
@@ -4207,7 +4212,7 @@
         </p:nvCxnSpPr>
         <p:spPr>
           <a:xfrm flipV="1">
-            <a:off x="12980884" y="5220998"/>
+            <a:off x="10807478" y="5220998"/>
             <a:ext cx="0" cy="14747884"/>
           </a:xfrm>
           <a:prstGeom prst="straightConnector1">
@@ -4429,6 +4434,735 @@
             <a:r>
               <a:rPr kumimoji="1" lang="en-US" altLang="ja-JP" dirty="0"/>
               <a:t>2.6cm</a:t>
+            </a:r>
+            <a:endParaRPr kumimoji="1" lang="ja-JP" altLang="en-US"/>
+          </a:p>
+        </p:txBody>
+      </p:sp>
+      <p:grpSp>
+        <p:nvGrpSpPr>
+          <p:cNvPr id="5" name="グループ化 4">
+            <a:extLst>
+              <a:ext uri="{FF2B5EF4-FFF2-40B4-BE49-F238E27FC236}">
+                <a16:creationId xmlns:a16="http://schemas.microsoft.com/office/drawing/2014/main" id="{3040AB51-6162-ACA7-DD8F-C2D28E474FDD}"/>
+              </a:ext>
+            </a:extLst>
+          </p:cNvPr>
+          <p:cNvGrpSpPr/>
+          <p:nvPr/>
+        </p:nvGrpSpPr>
+        <p:grpSpPr>
+          <a:xfrm>
+            <a:off x="12242018" y="7629297"/>
+            <a:ext cx="3960000" cy="2880000"/>
+            <a:chOff x="10627433" y="7543799"/>
+            <a:chExt cx="3960000" cy="2880000"/>
+          </a:xfrm>
+        </p:grpSpPr>
+        <p:sp>
+          <p:nvSpPr>
+            <p:cNvPr id="2" name="正方形/長方形 1">
+              <a:extLst>
+                <a:ext uri="{FF2B5EF4-FFF2-40B4-BE49-F238E27FC236}">
+                  <a16:creationId xmlns:a16="http://schemas.microsoft.com/office/drawing/2014/main" id="{1D1EE9FC-647D-435F-BBF6-F6BA21BB3FFF}"/>
+                </a:ext>
+              </a:extLst>
+            </p:cNvPr>
+            <p:cNvSpPr/>
+            <p:nvPr/>
+          </p:nvSpPr>
+          <p:spPr>
+            <a:xfrm>
+              <a:off x="10627433" y="7543799"/>
+              <a:ext cx="3960000" cy="720000"/>
+            </a:xfrm>
+            <a:prstGeom prst="rect">
+              <a:avLst/>
+            </a:prstGeom>
+            <a:solidFill>
+              <a:schemeClr val="accent3"/>
+            </a:solidFill>
+          </p:spPr>
+          <p:style>
+            <a:lnRef idx="2">
+              <a:schemeClr val="accent1">
+                <a:shade val="15000"/>
+              </a:schemeClr>
+            </a:lnRef>
+            <a:fillRef idx="1">
+              <a:schemeClr val="accent1"/>
+            </a:fillRef>
+            <a:effectRef idx="0">
+              <a:schemeClr val="accent1"/>
+            </a:effectRef>
+            <a:fontRef idx="minor">
+              <a:schemeClr val="lt1"/>
+            </a:fontRef>
+          </p:style>
+          <p:txBody>
+            <a:bodyPr rtlCol="0" anchor="ctr"/>
+            <a:lstStyle/>
+            <a:p>
+              <a:pPr algn="ctr"/>
+              <a:endParaRPr kumimoji="1" lang="ja-JP" altLang="en-US"/>
+            </a:p>
+          </p:txBody>
+        </p:sp>
+        <p:sp>
+          <p:nvSpPr>
+            <p:cNvPr id="3" name="正方形/長方形 2">
+              <a:extLst>
+                <a:ext uri="{FF2B5EF4-FFF2-40B4-BE49-F238E27FC236}">
+                  <a16:creationId xmlns:a16="http://schemas.microsoft.com/office/drawing/2014/main" id="{578462E9-6D17-9155-12B2-D9F8F31717D2}"/>
+                </a:ext>
+              </a:extLst>
+            </p:cNvPr>
+            <p:cNvSpPr/>
+            <p:nvPr/>
+          </p:nvSpPr>
+          <p:spPr>
+            <a:xfrm>
+              <a:off x="10627433" y="7543799"/>
+              <a:ext cx="3960000" cy="2880000"/>
+            </a:xfrm>
+            <a:prstGeom prst="rect">
+              <a:avLst/>
+            </a:prstGeom>
+            <a:noFill/>
+            <a:ln>
+              <a:solidFill>
+                <a:schemeClr val="tx1"/>
+              </a:solidFill>
+            </a:ln>
+          </p:spPr>
+          <p:style>
+            <a:lnRef idx="2">
+              <a:schemeClr val="accent1">
+                <a:shade val="15000"/>
+              </a:schemeClr>
+            </a:lnRef>
+            <a:fillRef idx="1">
+              <a:schemeClr val="accent1"/>
+            </a:fillRef>
+            <a:effectRef idx="0">
+              <a:schemeClr val="accent1"/>
+            </a:effectRef>
+            <a:fontRef idx="minor">
+              <a:schemeClr val="lt1"/>
+            </a:fontRef>
+          </p:style>
+          <p:txBody>
+            <a:bodyPr rtlCol="0" anchor="ctr"/>
+            <a:lstStyle/>
+            <a:p>
+              <a:pPr algn="ctr"/>
+              <a:endParaRPr kumimoji="1" lang="ja-JP" altLang="en-US"/>
+            </a:p>
+          </p:txBody>
+        </p:sp>
+      </p:grpSp>
+      <p:cxnSp>
+        <p:nvCxnSpPr>
+          <p:cNvPr id="8" name="直線矢印コネクタ 7">
+            <a:extLst>
+              <a:ext uri="{FF2B5EF4-FFF2-40B4-BE49-F238E27FC236}">
+                <a16:creationId xmlns:a16="http://schemas.microsoft.com/office/drawing/2014/main" id="{9A06467F-3798-750F-AF3E-15864798F533}"/>
+              </a:ext>
+            </a:extLst>
+          </p:cNvPr>
+          <p:cNvCxnSpPr>
+            <a:cxnSpLocks/>
+          </p:cNvCxnSpPr>
+          <p:nvPr/>
+        </p:nvCxnSpPr>
+        <p:spPr>
+          <a:xfrm flipV="1">
+            <a:off x="15671680" y="6173724"/>
+            <a:ext cx="0" cy="1455573"/>
+          </a:xfrm>
+          <a:prstGeom prst="straightConnector1">
+            <a:avLst/>
+          </a:prstGeom>
+          <a:ln>
+            <a:solidFill>
+              <a:srgbClr val="C00000"/>
+            </a:solidFill>
+            <a:headEnd type="triangle"/>
+            <a:tailEnd type="triangle"/>
+          </a:ln>
+        </p:spPr>
+        <p:style>
+          <a:lnRef idx="2">
+            <a:schemeClr val="accent1"/>
+          </a:lnRef>
+          <a:fillRef idx="0">
+            <a:schemeClr val="accent1"/>
+          </a:fillRef>
+          <a:effectRef idx="1">
+            <a:schemeClr val="accent1"/>
+          </a:effectRef>
+          <a:fontRef idx="minor">
+            <a:schemeClr val="tx1"/>
+          </a:fontRef>
+        </p:style>
+      </p:cxnSp>
+      <p:sp>
+        <p:nvSpPr>
+          <p:cNvPr id="10" name="テキスト ボックス 9">
+            <a:extLst>
+              <a:ext uri="{FF2B5EF4-FFF2-40B4-BE49-F238E27FC236}">
+                <a16:creationId xmlns:a16="http://schemas.microsoft.com/office/drawing/2014/main" id="{FBB39F1C-FB7E-A533-3D82-42D8C698FA52}"/>
+              </a:ext>
+            </a:extLst>
+          </p:cNvPr>
+          <p:cNvSpPr txBox="1"/>
+          <p:nvPr/>
+        </p:nvSpPr>
+        <p:spPr>
+          <a:xfrm>
+            <a:off x="15729314" y="6731617"/>
+            <a:ext cx="627095" cy="369332"/>
+          </a:xfrm>
+          <a:prstGeom prst="rect">
+            <a:avLst/>
+          </a:prstGeom>
+          <a:noFill/>
+        </p:spPr>
+        <p:txBody>
+          <a:bodyPr wrap="none" rtlCol="0">
+            <a:spAutoFit/>
+          </a:bodyPr>
+          <a:lstStyle/>
+          <a:p>
+            <a:r>
+              <a:rPr kumimoji="1" lang="en-US" altLang="ja-JP" dirty="0"/>
+              <a:t>5cm</a:t>
+            </a:r>
+            <a:endParaRPr kumimoji="1" lang="ja-JP" altLang="en-US"/>
+          </a:p>
+        </p:txBody>
+      </p:sp>
+      <p:cxnSp>
+        <p:nvCxnSpPr>
+          <p:cNvPr id="12" name="直線矢印コネクタ 11">
+            <a:extLst>
+              <a:ext uri="{FF2B5EF4-FFF2-40B4-BE49-F238E27FC236}">
+                <a16:creationId xmlns:a16="http://schemas.microsoft.com/office/drawing/2014/main" id="{CC48DE2F-8F27-0C12-FFB1-994DE85C1027}"/>
+              </a:ext>
+            </a:extLst>
+          </p:cNvPr>
+          <p:cNvCxnSpPr>
+            <a:cxnSpLocks/>
+          </p:cNvCxnSpPr>
+          <p:nvPr/>
+        </p:nvCxnSpPr>
+        <p:spPr>
+          <a:xfrm flipV="1">
+            <a:off x="16369418" y="7623285"/>
+            <a:ext cx="0" cy="726012"/>
+          </a:xfrm>
+          <a:prstGeom prst="straightConnector1">
+            <a:avLst/>
+          </a:prstGeom>
+          <a:ln>
+            <a:solidFill>
+              <a:srgbClr val="C00000"/>
+            </a:solidFill>
+            <a:headEnd type="triangle"/>
+            <a:tailEnd type="triangle"/>
+          </a:ln>
+        </p:spPr>
+        <p:style>
+          <a:lnRef idx="2">
+            <a:schemeClr val="accent1"/>
+          </a:lnRef>
+          <a:fillRef idx="0">
+            <a:schemeClr val="accent1"/>
+          </a:fillRef>
+          <a:effectRef idx="1">
+            <a:schemeClr val="accent1"/>
+          </a:effectRef>
+          <a:fontRef idx="minor">
+            <a:schemeClr val="tx1"/>
+          </a:fontRef>
+        </p:style>
+      </p:cxnSp>
+      <p:sp>
+        <p:nvSpPr>
+          <p:cNvPr id="13" name="テキスト ボックス 12">
+            <a:extLst>
+              <a:ext uri="{FF2B5EF4-FFF2-40B4-BE49-F238E27FC236}">
+                <a16:creationId xmlns:a16="http://schemas.microsoft.com/office/drawing/2014/main" id="{C3C661D4-19D2-999F-EA47-CFC4C62E6502}"/>
+              </a:ext>
+            </a:extLst>
+          </p:cNvPr>
+          <p:cNvSpPr txBox="1"/>
+          <p:nvPr/>
+        </p:nvSpPr>
+        <p:spPr>
+          <a:xfrm>
+            <a:off x="16471117" y="7854646"/>
+            <a:ext cx="627095" cy="369332"/>
+          </a:xfrm>
+          <a:prstGeom prst="rect">
+            <a:avLst/>
+          </a:prstGeom>
+          <a:noFill/>
+        </p:spPr>
+        <p:txBody>
+          <a:bodyPr wrap="none" rtlCol="0">
+            <a:spAutoFit/>
+          </a:bodyPr>
+          <a:lstStyle/>
+          <a:p>
+            <a:r>
+              <a:rPr kumimoji="1" lang="en-US" altLang="ja-JP" dirty="0"/>
+              <a:t>2cm</a:t>
+            </a:r>
+            <a:endParaRPr kumimoji="1" lang="ja-JP" altLang="en-US"/>
+          </a:p>
+        </p:txBody>
+      </p:sp>
+      <p:cxnSp>
+        <p:nvCxnSpPr>
+          <p:cNvPr id="16" name="直線矢印コネクタ 15">
+            <a:extLst>
+              <a:ext uri="{FF2B5EF4-FFF2-40B4-BE49-F238E27FC236}">
+                <a16:creationId xmlns:a16="http://schemas.microsoft.com/office/drawing/2014/main" id="{371770E4-9F94-CC89-313A-FCB8F64900FC}"/>
+              </a:ext>
+            </a:extLst>
+          </p:cNvPr>
+          <p:cNvCxnSpPr>
+            <a:cxnSpLocks/>
+          </p:cNvCxnSpPr>
+          <p:nvPr/>
+        </p:nvCxnSpPr>
+        <p:spPr>
+          <a:xfrm>
+            <a:off x="12236557" y="8587291"/>
+            <a:ext cx="3988036" cy="0"/>
+          </a:xfrm>
+          <a:prstGeom prst="straightConnector1">
+            <a:avLst/>
+          </a:prstGeom>
+          <a:ln>
+            <a:solidFill>
+              <a:srgbClr val="C00000"/>
+            </a:solidFill>
+            <a:headEnd type="triangle"/>
+            <a:tailEnd type="triangle"/>
+          </a:ln>
+        </p:spPr>
+        <p:style>
+          <a:lnRef idx="2">
+            <a:schemeClr val="accent1"/>
+          </a:lnRef>
+          <a:fillRef idx="0">
+            <a:schemeClr val="accent1"/>
+          </a:fillRef>
+          <a:effectRef idx="1">
+            <a:schemeClr val="accent1"/>
+          </a:effectRef>
+          <a:fontRef idx="minor">
+            <a:schemeClr val="tx1"/>
+          </a:fontRef>
+        </p:style>
+      </p:cxnSp>
+      <p:sp>
+        <p:nvSpPr>
+          <p:cNvPr id="17" name="テキスト ボックス 16">
+            <a:extLst>
+              <a:ext uri="{FF2B5EF4-FFF2-40B4-BE49-F238E27FC236}">
+                <a16:creationId xmlns:a16="http://schemas.microsoft.com/office/drawing/2014/main" id="{40E0C8AD-34E9-DB6F-4480-B998532D71BE}"/>
+              </a:ext>
+            </a:extLst>
+          </p:cNvPr>
+          <p:cNvSpPr txBox="1"/>
+          <p:nvPr/>
+        </p:nvSpPr>
+        <p:spPr>
+          <a:xfrm>
+            <a:off x="13741423" y="8683737"/>
+            <a:ext cx="750526" cy="369332"/>
+          </a:xfrm>
+          <a:prstGeom prst="rect">
+            <a:avLst/>
+          </a:prstGeom>
+          <a:noFill/>
+        </p:spPr>
+        <p:txBody>
+          <a:bodyPr wrap="square" rtlCol="0">
+            <a:spAutoFit/>
+          </a:bodyPr>
+          <a:lstStyle/>
+          <a:p>
+            <a:r>
+              <a:rPr kumimoji="1" lang="en-US" altLang="ja-JP" dirty="0"/>
+              <a:t>8cm</a:t>
+            </a:r>
+            <a:endParaRPr kumimoji="1" lang="ja-JP" altLang="en-US"/>
+          </a:p>
+        </p:txBody>
+      </p:sp>
+      <p:grpSp>
+        <p:nvGrpSpPr>
+          <p:cNvPr id="20" name="グループ化 19">
+            <a:extLst>
+              <a:ext uri="{FF2B5EF4-FFF2-40B4-BE49-F238E27FC236}">
+                <a16:creationId xmlns:a16="http://schemas.microsoft.com/office/drawing/2014/main" id="{BCADCA20-B1B7-D66F-7896-395A2B655AB6}"/>
+              </a:ext>
+            </a:extLst>
+          </p:cNvPr>
+          <p:cNvGrpSpPr/>
+          <p:nvPr/>
+        </p:nvGrpSpPr>
+        <p:grpSpPr>
+          <a:xfrm>
+            <a:off x="25919644" y="15659988"/>
+            <a:ext cx="4320000" cy="4320000"/>
+            <a:chOff x="10627433" y="7543799"/>
+            <a:chExt cx="3960000" cy="2880000"/>
+          </a:xfrm>
+        </p:grpSpPr>
+        <p:sp>
+          <p:nvSpPr>
+            <p:cNvPr id="25" name="正方形/長方形 24">
+              <a:extLst>
+                <a:ext uri="{FF2B5EF4-FFF2-40B4-BE49-F238E27FC236}">
+                  <a16:creationId xmlns:a16="http://schemas.microsoft.com/office/drawing/2014/main" id="{A247DB41-1A38-9F87-3819-966D5E6C42ED}"/>
+                </a:ext>
+              </a:extLst>
+            </p:cNvPr>
+            <p:cNvSpPr/>
+            <p:nvPr/>
+          </p:nvSpPr>
+          <p:spPr>
+            <a:xfrm>
+              <a:off x="10627433" y="7543799"/>
+              <a:ext cx="3960000" cy="480000"/>
+            </a:xfrm>
+            <a:prstGeom prst="rect">
+              <a:avLst/>
+            </a:prstGeom>
+            <a:solidFill>
+              <a:schemeClr val="accent3"/>
+            </a:solidFill>
+          </p:spPr>
+          <p:style>
+            <a:lnRef idx="2">
+              <a:schemeClr val="accent1">
+                <a:shade val="15000"/>
+              </a:schemeClr>
+            </a:lnRef>
+            <a:fillRef idx="1">
+              <a:schemeClr val="accent1"/>
+            </a:fillRef>
+            <a:effectRef idx="0">
+              <a:schemeClr val="accent1"/>
+            </a:effectRef>
+            <a:fontRef idx="minor">
+              <a:schemeClr val="lt1"/>
+            </a:fontRef>
+          </p:style>
+          <p:txBody>
+            <a:bodyPr rtlCol="0" anchor="ctr"/>
+            <a:lstStyle/>
+            <a:p>
+              <a:pPr algn="ctr"/>
+              <a:endParaRPr kumimoji="1" lang="ja-JP" altLang="en-US"/>
+            </a:p>
+          </p:txBody>
+        </p:sp>
+        <p:sp>
+          <p:nvSpPr>
+            <p:cNvPr id="26" name="正方形/長方形 25">
+              <a:extLst>
+                <a:ext uri="{FF2B5EF4-FFF2-40B4-BE49-F238E27FC236}">
+                  <a16:creationId xmlns:a16="http://schemas.microsoft.com/office/drawing/2014/main" id="{E0D1620F-A17B-3B80-97EB-63BB463F59D1}"/>
+                </a:ext>
+              </a:extLst>
+            </p:cNvPr>
+            <p:cNvSpPr/>
+            <p:nvPr/>
+          </p:nvSpPr>
+          <p:spPr>
+            <a:xfrm>
+              <a:off x="10627433" y="7543799"/>
+              <a:ext cx="3960000" cy="2880000"/>
+            </a:xfrm>
+            <a:prstGeom prst="rect">
+              <a:avLst/>
+            </a:prstGeom>
+            <a:noFill/>
+            <a:ln>
+              <a:solidFill>
+                <a:schemeClr val="tx1"/>
+              </a:solidFill>
+            </a:ln>
+          </p:spPr>
+          <p:style>
+            <a:lnRef idx="2">
+              <a:schemeClr val="accent1">
+                <a:shade val="15000"/>
+              </a:schemeClr>
+            </a:lnRef>
+            <a:fillRef idx="1">
+              <a:schemeClr val="accent1"/>
+            </a:fillRef>
+            <a:effectRef idx="0">
+              <a:schemeClr val="accent1"/>
+            </a:effectRef>
+            <a:fontRef idx="minor">
+              <a:schemeClr val="lt1"/>
+            </a:fontRef>
+          </p:style>
+          <p:txBody>
+            <a:bodyPr rtlCol="0" anchor="ctr"/>
+            <a:lstStyle/>
+            <a:p>
+              <a:pPr algn="ctr"/>
+              <a:endParaRPr kumimoji="1" lang="ja-JP" altLang="en-US"/>
+            </a:p>
+          </p:txBody>
+        </p:sp>
+      </p:grpSp>
+      <p:cxnSp>
+        <p:nvCxnSpPr>
+          <p:cNvPr id="27" name="直線矢印コネクタ 26">
+            <a:extLst>
+              <a:ext uri="{FF2B5EF4-FFF2-40B4-BE49-F238E27FC236}">
+                <a16:creationId xmlns:a16="http://schemas.microsoft.com/office/drawing/2014/main" id="{9CB95D0D-3D2B-6DEB-0BF4-A6447EB67FA2}"/>
+              </a:ext>
+            </a:extLst>
+          </p:cNvPr>
+          <p:cNvCxnSpPr>
+            <a:cxnSpLocks/>
+          </p:cNvCxnSpPr>
+          <p:nvPr/>
+        </p:nvCxnSpPr>
+        <p:spPr>
+          <a:xfrm flipV="1">
+            <a:off x="4752837" y="10903120"/>
+            <a:ext cx="0" cy="3384000"/>
+          </a:xfrm>
+          <a:prstGeom prst="straightConnector1">
+            <a:avLst/>
+          </a:prstGeom>
+          <a:ln>
+            <a:solidFill>
+              <a:srgbClr val="C00000"/>
+            </a:solidFill>
+            <a:headEnd type="triangle"/>
+            <a:tailEnd type="triangle"/>
+          </a:ln>
+        </p:spPr>
+        <p:style>
+          <a:lnRef idx="2">
+            <a:schemeClr val="accent1"/>
+          </a:lnRef>
+          <a:fillRef idx="0">
+            <a:schemeClr val="accent1"/>
+          </a:fillRef>
+          <a:effectRef idx="1">
+            <a:schemeClr val="accent1"/>
+          </a:effectRef>
+          <a:fontRef idx="minor">
+            <a:schemeClr val="tx1"/>
+          </a:fontRef>
+        </p:style>
+      </p:cxnSp>
+      <p:sp>
+        <p:nvSpPr>
+          <p:cNvPr id="29" name="テキスト ボックス 28">
+            <a:extLst>
+              <a:ext uri="{FF2B5EF4-FFF2-40B4-BE49-F238E27FC236}">
+                <a16:creationId xmlns:a16="http://schemas.microsoft.com/office/drawing/2014/main" id="{A85CEDB4-CB92-CD3A-2AA2-F2D707C9EBAD}"/>
+              </a:ext>
+            </a:extLst>
+          </p:cNvPr>
+          <p:cNvSpPr txBox="1"/>
+          <p:nvPr/>
+        </p:nvSpPr>
+        <p:spPr>
+          <a:xfrm>
+            <a:off x="3882301" y="12920579"/>
+            <a:ext cx="816249" cy="369332"/>
+          </a:xfrm>
+          <a:prstGeom prst="rect">
+            <a:avLst/>
+          </a:prstGeom>
+          <a:noFill/>
+        </p:spPr>
+        <p:txBody>
+          <a:bodyPr wrap="none" rtlCol="0">
+            <a:spAutoFit/>
+          </a:bodyPr>
+          <a:lstStyle/>
+          <a:p>
+            <a:r>
+              <a:rPr kumimoji="1" lang="en-US" altLang="ja-JP" dirty="0"/>
+              <a:t>9.4cm</a:t>
+            </a:r>
+            <a:endParaRPr kumimoji="1" lang="ja-JP" altLang="en-US"/>
+          </a:p>
+        </p:txBody>
+      </p:sp>
+      <p:sp>
+        <p:nvSpPr>
+          <p:cNvPr id="37" name="テキスト ボックス 36">
+            <a:extLst>
+              <a:ext uri="{FF2B5EF4-FFF2-40B4-BE49-F238E27FC236}">
+                <a16:creationId xmlns:a16="http://schemas.microsoft.com/office/drawing/2014/main" id="{DD213996-97F4-F33D-77C3-9F06B1EE82C6}"/>
+              </a:ext>
+            </a:extLst>
+          </p:cNvPr>
+          <p:cNvSpPr txBox="1"/>
+          <p:nvPr/>
+        </p:nvSpPr>
+        <p:spPr>
+          <a:xfrm>
+            <a:off x="20906511" y="15531461"/>
+            <a:ext cx="939681" cy="369332"/>
+          </a:xfrm>
+          <a:prstGeom prst="rect">
+            <a:avLst/>
+          </a:prstGeom>
+          <a:noFill/>
+        </p:spPr>
+        <p:txBody>
+          <a:bodyPr wrap="square" rtlCol="0">
+            <a:spAutoFit/>
+          </a:bodyPr>
+          <a:lstStyle/>
+          <a:p>
+            <a:r>
+              <a:rPr kumimoji="1" lang="en-US" altLang="ja-JP" dirty="0"/>
+              <a:t>27cm</a:t>
+            </a:r>
+            <a:endParaRPr kumimoji="1" lang="ja-JP" altLang="en-US"/>
+          </a:p>
+        </p:txBody>
+      </p:sp>
+      <p:cxnSp>
+        <p:nvCxnSpPr>
+          <p:cNvPr id="38" name="直線矢印コネクタ 37">
+            <a:extLst>
+              <a:ext uri="{FF2B5EF4-FFF2-40B4-BE49-F238E27FC236}">
+                <a16:creationId xmlns:a16="http://schemas.microsoft.com/office/drawing/2014/main" id="{D7C9478D-09C3-4761-B980-EC923DDD9907}"/>
+              </a:ext>
+            </a:extLst>
+          </p:cNvPr>
+          <p:cNvCxnSpPr>
+            <a:cxnSpLocks/>
+          </p:cNvCxnSpPr>
+          <p:nvPr/>
+        </p:nvCxnSpPr>
+        <p:spPr>
+          <a:xfrm>
+            <a:off x="16199643" y="16029250"/>
+            <a:ext cx="9720001" cy="0"/>
+          </a:xfrm>
+          <a:prstGeom prst="straightConnector1">
+            <a:avLst/>
+          </a:prstGeom>
+          <a:ln>
+            <a:solidFill>
+              <a:srgbClr val="C00000"/>
+            </a:solidFill>
+            <a:headEnd type="triangle"/>
+            <a:tailEnd type="triangle"/>
+          </a:ln>
+        </p:spPr>
+        <p:style>
+          <a:lnRef idx="2">
+            <a:schemeClr val="accent1"/>
+          </a:lnRef>
+          <a:fillRef idx="0">
+            <a:schemeClr val="accent1"/>
+          </a:fillRef>
+          <a:effectRef idx="1">
+            <a:schemeClr val="accent1"/>
+          </a:effectRef>
+          <a:fontRef idx="minor">
+            <a:schemeClr val="tx1"/>
+          </a:fontRef>
+        </p:style>
+      </p:cxnSp>
+      <p:sp>
+        <p:nvSpPr>
+          <p:cNvPr id="9" name="テキスト ボックス 8">
+            <a:extLst>
+              <a:ext uri="{FF2B5EF4-FFF2-40B4-BE49-F238E27FC236}">
+                <a16:creationId xmlns:a16="http://schemas.microsoft.com/office/drawing/2014/main" id="{E2A113AB-CC60-FCF7-62C4-D102936174AD}"/>
+              </a:ext>
+            </a:extLst>
+          </p:cNvPr>
+          <p:cNvSpPr txBox="1"/>
+          <p:nvPr/>
+        </p:nvSpPr>
+        <p:spPr>
+          <a:xfrm>
+            <a:off x="14267054" y="9133373"/>
+            <a:ext cx="1904689" cy="369332"/>
+          </a:xfrm>
+          <a:prstGeom prst="rect">
+            <a:avLst/>
+          </a:prstGeom>
+          <a:noFill/>
+        </p:spPr>
+        <p:txBody>
+          <a:bodyPr wrap="none" rtlCol="0">
+            <a:spAutoFit/>
+          </a:bodyPr>
+          <a:lstStyle/>
+          <a:p>
+            <a:r>
+              <a:rPr kumimoji="1" lang="ja-JP" altLang="en-US"/>
+              <a:t>壁の高さは</a:t>
+            </a:r>
+            <a:r>
+              <a:rPr kumimoji="1" lang="en-US" altLang="ja-JP" dirty="0"/>
+              <a:t>16cm</a:t>
+            </a:r>
+            <a:endParaRPr kumimoji="1" lang="ja-JP" altLang="en-US"/>
+          </a:p>
+        </p:txBody>
+      </p:sp>
+      <p:sp>
+        <p:nvSpPr>
+          <p:cNvPr id="15" name="テキスト ボックス 14">
+            <a:extLst>
+              <a:ext uri="{FF2B5EF4-FFF2-40B4-BE49-F238E27FC236}">
+                <a16:creationId xmlns:a16="http://schemas.microsoft.com/office/drawing/2014/main" id="{CFBCEC76-3F29-09A1-DBF8-D5BE86E33A12}"/>
+              </a:ext>
+            </a:extLst>
+          </p:cNvPr>
+          <p:cNvSpPr txBox="1"/>
+          <p:nvPr/>
+        </p:nvSpPr>
+        <p:spPr>
+          <a:xfrm>
+            <a:off x="27216847" y="16489964"/>
+            <a:ext cx="1904689" cy="369332"/>
+          </a:xfrm>
+          <a:prstGeom prst="rect">
+            <a:avLst/>
+          </a:prstGeom>
+          <a:noFill/>
+        </p:spPr>
+        <p:txBody>
+          <a:bodyPr wrap="none" rtlCol="0">
+            <a:spAutoFit/>
+          </a:bodyPr>
+          <a:lstStyle/>
+          <a:p>
+            <a:r>
+              <a:rPr kumimoji="1" lang="ja-JP" altLang="en-US"/>
+              <a:t>壁の高さは</a:t>
+            </a:r>
+            <a:r>
+              <a:rPr kumimoji="1" lang="en-US" altLang="ja-JP" dirty="0"/>
+              <a:t>17cm</a:t>
             </a:r>
             <a:endParaRPr kumimoji="1" lang="ja-JP" altLang="en-US"/>
           </a:p>

</xml_diff>